<commit_message>
docs(homer): add UI screenshot to overview deck
</commit_message>
<xml_diff>
--- a/docs/T3-Homer-brief-overview.pptx
+++ b/docs/T3-Homer-brief-overview.pptx
@@ -3224,7 +3224,12 @@
             <p:ph idx="1"/>
           </p:nvPr>
         </p:nvSpPr>
-        <p:spPr/>
+        <p:spPr>
+          <a:xfrm>
+            <a:off x="457200" y="1600200"/>
+            <a:ext cx="8229600" cy="1325880"/>
+          </a:xfrm>
+        </p:spPr>
         <p:txBody>
           <a:bodyPr/>
           <a:lstStyle/>
@@ -3233,47 +3238,83 @@
               <a:defRPr sz="2000"/>
             </a:pPr>
             <a:r>
-              <a:t>Session control + thread authority</a:t>
-            </a:r>
-          </a:p>
-          <a:p>
-            <a:pPr>
-              <a:defRPr sz="2200"/>
-            </a:pPr>
-            <a:r>
-              <a:t>Normal path: supervise active session and watch warnings/errors/compaction/checkpoint state.</a:t>
-            </a:r>
-          </a:p>
-          <a:p>
-            <a:pPr>
-              <a:defRPr sz="2200"/>
-            </a:pPr>
-            <a:r>
-              <a:t>Primary recovery: restart_in_place (fresh provider session on same thread).</a:t>
-            </a:r>
-          </a:p>
-          <a:p>
-            <a:pPr>
-              <a:defRPr sz="2200"/>
-            </a:pPr>
-            <a:r>
-              <a:t>Escalation path: spawn_successor_thread after repeated restart failures/hard triggers.</a:t>
-            </a:r>
-          </a:p>
-          <a:p>
-            <a:pPr>
-              <a:defRPr sz="2200"/>
-            </a:pPr>
-            <a:r>
-              <a:t>On successor promotion: old thread is retired, new thread becomes active authority.</a:t>
-            </a:r>
-          </a:p>
-          <a:p>
-            <a:pPr>
-              <a:defRPr sz="2200"/>
-            </a:pPr>
-            <a:r>
-              <a:t>If recovery keeps failing, Homer sets manual_attention instead of looping forever.</a:t>
+              <a:rPr sz="1800"/>
+              <a:t>Session control + thread authority (deterministic rules)</a:t>
+            </a:r>
+          </a:p>
+          <a:p>
+            <a:pPr/>
+            <a:r>
+              <a:rPr sz="1600"/>
+              <a:t>Primary recovery: restart_in_place (fresh session, same thread)</a:t>
+            </a:r>
+          </a:p>
+          <a:p>
+            <a:pPr/>
+            <a:r>
+              <a:rPr sz="1600"/>
+              <a:t>Escalation: spawn_successor_thread after repeated failure/hard triggers</a:t>
+            </a:r>
+          </a:p>
+          <a:p>
+            <a:pPr/>
+            <a:r>
+              <a:rPr sz="1600"/>
+              <a:t>UI example below: activity log + Homer status counters for same-thread/new-thread</a:t>
+            </a:r>
+          </a:p>
+        </p:txBody>
+      </p:sp>
+      <p:pic>
+        <p:nvPicPr>
+          <p:cNvPr id="4" name="HomerUiScreenshot" descr="homer-ui-session-example.png"/>
+          <p:cNvPicPr>
+            <a:picLocks noChangeAspect="1"/>
+          </p:cNvPicPr>
+          <p:nvPr/>
+        </p:nvPicPr>
+        <p:blipFill>
+          <a:blip r:embed="rId2"/>
+          <a:stretch>
+            <a:fillRect/>
+          </a:stretch>
+        </p:blipFill>
+        <p:spPr>
+          <a:xfrm>
+            <a:off x="502920" y="2788920"/>
+            <a:ext cx="8138160" cy="5776240"/>
+          </a:xfrm>
+          <a:prstGeom prst="rect">
+            <a:avLst/>
+          </a:prstGeom>
+        </p:spPr>
+      </p:pic>
+      <p:sp>
+        <p:nvSpPr>
+          <p:cNvPr id="5" name="HomerUiCaption"/>
+          <p:cNvSpPr txBox="1"/>
+          <p:nvPr/>
+        </p:nvSpPr>
+        <p:spPr>
+          <a:xfrm>
+            <a:off x="502920" y="6355080"/>
+            <a:ext cx="8138160" cy="320040"/>
+          </a:xfrm>
+          <a:prstGeom prst="rect">
+            <a:avLst/>
+          </a:prstGeom>
+          <a:noFill/>
+        </p:spPr>
+        <p:txBody>
+          <a:bodyPr wrap="none">
+            <a:spAutoFit/>
+          </a:bodyPr>
+          <a:lstStyle/>
+          <a:p>
+            <a:pPr/>
+            <a:r>
+              <a:rPr sz="1200"/>
+              <a:t>Eksempel fra T3 Homer: arbeidslogg, session-tilstand og Homer-metrikker i sidebar.</a:t>
             </a:r>
           </a:p>
         </p:txBody>

</xml_diff>